<commit_message>
rm: delete unwanted temp file
</commit_message>
<xml_diff>
--- a/design/UI_UX/ui_concept.pptx
+++ b/design/UI_UX/ui_concept.pptx
@@ -256,7 +256,7 @@
           <a:p>
             <a:fld id="{0F81A39B-22B8-4687-AF26-014B09D9CCD9}" type="datetimeFigureOut">
               <a:rPr lang="vi-VN" smtClean="0"/>
-              <a:t>06/04/2026</a:t>
+              <a:t>09/04/2026</a:t>
             </a:fld>
             <a:endParaRPr lang="vi-VN"/>
           </a:p>
@@ -426,7 +426,7 @@
           <a:p>
             <a:fld id="{0F81A39B-22B8-4687-AF26-014B09D9CCD9}" type="datetimeFigureOut">
               <a:rPr lang="vi-VN" smtClean="0"/>
-              <a:t>06/04/2026</a:t>
+              <a:t>09/04/2026</a:t>
             </a:fld>
             <a:endParaRPr lang="vi-VN"/>
           </a:p>
@@ -606,7 +606,7 @@
           <a:p>
             <a:fld id="{0F81A39B-22B8-4687-AF26-014B09D9CCD9}" type="datetimeFigureOut">
               <a:rPr lang="vi-VN" smtClean="0"/>
-              <a:t>06/04/2026</a:t>
+              <a:t>09/04/2026</a:t>
             </a:fld>
             <a:endParaRPr lang="vi-VN"/>
           </a:p>
@@ -776,7 +776,7 @@
           <a:p>
             <a:fld id="{0F81A39B-22B8-4687-AF26-014B09D9CCD9}" type="datetimeFigureOut">
               <a:rPr lang="vi-VN" smtClean="0"/>
-              <a:t>06/04/2026</a:t>
+              <a:t>09/04/2026</a:t>
             </a:fld>
             <a:endParaRPr lang="vi-VN"/>
           </a:p>
@@ -1022,7 +1022,7 @@
           <a:p>
             <a:fld id="{0F81A39B-22B8-4687-AF26-014B09D9CCD9}" type="datetimeFigureOut">
               <a:rPr lang="vi-VN" smtClean="0"/>
-              <a:t>06/04/2026</a:t>
+              <a:t>09/04/2026</a:t>
             </a:fld>
             <a:endParaRPr lang="vi-VN"/>
           </a:p>
@@ -1254,7 +1254,7 @@
           <a:p>
             <a:fld id="{0F81A39B-22B8-4687-AF26-014B09D9CCD9}" type="datetimeFigureOut">
               <a:rPr lang="vi-VN" smtClean="0"/>
-              <a:t>06/04/2026</a:t>
+              <a:t>09/04/2026</a:t>
             </a:fld>
             <a:endParaRPr lang="vi-VN"/>
           </a:p>
@@ -1621,7 +1621,7 @@
           <a:p>
             <a:fld id="{0F81A39B-22B8-4687-AF26-014B09D9CCD9}" type="datetimeFigureOut">
               <a:rPr lang="vi-VN" smtClean="0"/>
-              <a:t>06/04/2026</a:t>
+              <a:t>09/04/2026</a:t>
             </a:fld>
             <a:endParaRPr lang="vi-VN"/>
           </a:p>
@@ -1739,7 +1739,7 @@
           <a:p>
             <a:fld id="{0F81A39B-22B8-4687-AF26-014B09D9CCD9}" type="datetimeFigureOut">
               <a:rPr lang="vi-VN" smtClean="0"/>
-              <a:t>06/04/2026</a:t>
+              <a:t>09/04/2026</a:t>
             </a:fld>
             <a:endParaRPr lang="vi-VN"/>
           </a:p>
@@ -1834,7 +1834,7 @@
           <a:p>
             <a:fld id="{0F81A39B-22B8-4687-AF26-014B09D9CCD9}" type="datetimeFigureOut">
               <a:rPr lang="vi-VN" smtClean="0"/>
-              <a:t>06/04/2026</a:t>
+              <a:t>09/04/2026</a:t>
             </a:fld>
             <a:endParaRPr lang="vi-VN"/>
           </a:p>
@@ -2111,7 +2111,7 @@
           <a:p>
             <a:fld id="{0F81A39B-22B8-4687-AF26-014B09D9CCD9}" type="datetimeFigureOut">
               <a:rPr lang="vi-VN" smtClean="0"/>
-              <a:t>06/04/2026</a:t>
+              <a:t>09/04/2026</a:t>
             </a:fld>
             <a:endParaRPr lang="vi-VN"/>
           </a:p>
@@ -2368,7 +2368,7 @@
           <a:p>
             <a:fld id="{0F81A39B-22B8-4687-AF26-014B09D9CCD9}" type="datetimeFigureOut">
               <a:rPr lang="vi-VN" smtClean="0"/>
-              <a:t>06/04/2026</a:t>
+              <a:t>09/04/2026</a:t>
             </a:fld>
             <a:endParaRPr lang="vi-VN"/>
           </a:p>
@@ -2581,7 +2581,7 @@
           <a:p>
             <a:fld id="{0F81A39B-22B8-4687-AF26-014B09D9CCD9}" type="datetimeFigureOut">
               <a:rPr lang="vi-VN" smtClean="0"/>
-              <a:t>06/04/2026</a:t>
+              <a:t>09/04/2026</a:t>
             </a:fld>
             <a:endParaRPr lang="vi-VN"/>
           </a:p>
@@ -37410,14 +37410,18 @@
             <a:r>
               <a:rPr lang="en-US" sz="1200" b="1" dirty="0">
                 <a:solidFill>
-                  <a:schemeClr val="tx2"/>
+                  <a:schemeClr val="accent4">
+                    <a:lumMod val="50000"/>
+                  </a:schemeClr>
                 </a:solidFill>
               </a:rPr>
               <a:t>Administrator</a:t>
             </a:r>
             <a:endParaRPr lang="vi-VN" sz="1200" b="1" dirty="0">
               <a:solidFill>
-                <a:schemeClr val="tx2"/>
+                <a:schemeClr val="accent4">
+                  <a:lumMod val="50000"/>
+                </a:schemeClr>
               </a:solidFill>
             </a:endParaRPr>
           </a:p>

</xml_diff>